<commit_message>
docs: add glossary, technical explainers, and presentation materials
Add bilingual glossary and deep-dive guides for core mechanics (IV/LP guard, Tier 2 pricing, Poisson lambda, trading fees). Link from README/FAQ and refresh overview slide decks with companion speaker notes.

Co-authored-by: Cursor <cursoragent@cursor.com>
</commit_message>
<xml_diff>
--- a/docs/presentations/X-Market-Sui-Overview.en.pptx
+++ b/docs/presentations/X-Market-Sui-Overview.en.pptx
@@ -6,6 +6,7 @@
   </p:sldMasterIdLst>
   <p:sldIdLst>
     <p:sldId id="256" r:id="rId2"/>
+    <p:sldId id="272" r:id="rId23"/>
     <p:sldId id="257" r:id="rId3"/>
     <p:sldId id="258" r:id="rId4"/>
     <p:sldId id="259" r:id="rId5"/>
@@ -20,6 +21,7 @@
     <p:sldId id="268" r:id="rId14"/>
     <p:sldId id="269" r:id="rId15"/>
     <p:sldId id="270" r:id="rId16"/>
+    <p:sldId id="273" r:id="rId24"/>
     <p:sldId id="271" r:id="rId17"/>
   </p:sldIdLst>
   <p:notesMasterIdLst>
@@ -1173,6 +1175,321 @@
     <a:masterClrMapping/>
   </p:clrMapOvr>
 </p:notes>
+</file>
+
+<file path=ppt/notesSlides/notesSlide18.xml><?xml version="1.0" encoding="utf-8"?>
+<p:notes xmlns:a="http://schemas.openxmlformats.org/drawingml/2006/main" xmlns:r="http://schemas.openxmlformats.org/officeDocument/2006/relationships" xmlns:p="http://schemas.openxmlformats.org/presentationml/2006/main">
+  
+  
+  <p:cSld>
+    
+    
+    <p:spTree>
+      
+      
+      <p:nvGrpSpPr>
+        
+        
+        <p:cNvPr id="1" name=""/>
+        
+        
+        <p:cNvGrpSpPr/>
+        
+        
+        <p:nvPr/>
+        
+      
+      </p:nvGrpSpPr>
+      
+      
+      <p:grpSpPr>
+        
+        
+        <a:xfrm>
+          
+          
+          <a:off x="0" y="0"/>
+          
+          
+          <a:ext cx="0" cy="0"/>
+          
+          
+          <a:chOff x="0" y="0"/>
+          
+          
+          <a:chExt cx="0" cy="0"/>
+          
+        
+        </a:xfrm>
+        
+      
+      </p:grpSpPr>
+      
+      
+      <p:sp>
+        
+        
+        <p:nvSpPr>
+          
+          
+          <p:cNvPr id="2" name="Slide Image Placeholder 1"/>
+          
+          
+          <p:cNvSpPr>
+            
+            
+            <a:spLocks noGrp="1" noRot="1" noChangeAspect="1"/>
+            
+          
+          </p:cNvSpPr>
+          
+          
+          <p:nvPr>
+            
+            
+            <p:ph type="sldImg"/>
+            
+          
+          </p:nvPr>
+          
+        
+        </p:nvSpPr>
+        
+        
+        <p:spPr/>
+        
+      
+      </p:sp>
+      
+      
+      <p:sp>
+        
+        
+        <p:nvSpPr>
+          
+          
+          <p:cNvPr id="3" name="Notes Placeholder 2"/>
+          
+          
+          <p:cNvSpPr>
+            
+            
+            <a:spLocks noGrp="1"/>
+            
+          
+          </p:cNvSpPr>
+          
+          
+          <p:nvPr>
+            
+            
+            <p:ph type="body" idx="1"/>
+            
+          
+          </p:nvPr>
+          
+        
+        </p:nvSpPr>
+        
+        
+        <p:spPr/>
+        
+        
+        <p:txBody>
+          
+          
+          <a:bodyPr/>
+          
+          
+          <a:lstStyle/>
+          
+          
+          <a:p>
+            <a:r>
+              <a:rPr lang="en-US" dirty="0"/>
+              <a:t>Video narration (~75 sec)</a:t>
+            </a:r>
+            <a:endParaRPr lang="en-US" dirty="0"/>
+          </a:p>
+          <a:p>
+            <a:r>
+              <a:rPr lang="en-US" dirty="0"/>
+              <a:t></a:t>
+            </a:r>
+            <a:endParaRPr lang="en-US" dirty="0"/>
+          </a:p>
+          <a:p>
+            <a:r>
+              <a:rPr lang="en-US" dirty="0"/>
+              <a:t>Having walked through the full stack, we close with Conclusion & Future.</a:t>
+            </a:r>
+            <a:endParaRPr lang="en-US" dirty="0"/>
+          </a:p>
+          <a:p>
+            <a:r>
+              <a:rPr lang="en-US" dirty="0"/>
+              <a:t></a:t>
+            </a:r>
+            <a:endParaRPr lang="en-US" dirty="0"/>
+          </a:p>
+          <a:p>
+            <a:r>
+              <a:rPr lang="en-US" dirty="0"/>
+              <a:t>On conclusion: X-Market is not "another prediction market." It upgrades prediction from Yes/No gambling to PDF probability derivatives. Trading and SuiProphet share one EventRoot and one Oracle — bets, unlocks, and settlement point to a single truth for each event. On-chain PDF pricing plus Seal-mandated audit creates a sustainable ecosystem for traders, LPs, prophets, and the protocol. Testnet v2 is live end-to-end — this is validated product, not a concept.</a:t>
+            </a:r>
+            <a:endParaRPr lang="en-US" dirty="0"/>
+          </a:p>
+          <a:p>
+            <a:r>
+              <a:rPr lang="en-US" dirty="0"/>
+              <a:t></a:t>
+            </a:r>
+            <a:endParaRPr lang="en-US" dirty="0"/>
+          </a:p>
+          <a:p>
+            <a:r>
+              <a:rPr lang="en-US" dirty="0"/>
+              <a:t>On the near term: Phase 3 wraps Variance Swap and Slash governance, plus the ZK Attestation cold path from mock to live — Brevis Prover registers proof_hash with a 3600s challenge window, never blocking the buy_* hot path. On PDF: Beta distribution for vote share, dual-pool joint probability, and more vertical markets in parallel. External audit then Mainnet; Circle USDC mainnet settlement lands together. GeoBlock is frontend-only IP-based web access restriction for compliance — not KYC, and it does not block direct on-chain interaction.</a:t>
+            </a:r>
+            <a:endParaRPr lang="en-US" dirty="0"/>
+          </a:p>
+          <a:p>
+            <a:r>
+              <a:rPr lang="en-US" dirty="0"/>
+              <a:t></a:t>
+            </a:r>
+            <a:endParaRPr lang="en-US" dirty="0"/>
+          </a:p>
+          <a:p>
+            <a:r>
+              <a:rPr lang="en-US" dirty="0"/>
+              <a:t>Long term: become Sui's infrastructure layer for probability derivatives and on-chain paid knowledge — serving retail, LPs, professional prophets, and quant firms. Full EventRoot migration and open SDK / Quant API. Replace fragmented Yes/No with on-chain PDF; replace fake signal-selling with forced audit. That's the endgame.</a:t>
+            </a:r>
+            <a:endParaRPr lang="en-US" dirty="0"/>
+          </a:p>
+          <a:p>
+            <a:r>
+              <a:rPr lang="en-US" dirty="0"/>
+              <a:t></a:t>
+            </a:r>
+            <a:endParaRPr lang="en-US" dirty="0"/>
+          </a:p>
+          <a:p>
+            <a:r>
+              <a:rPr lang="en-US" dirty="0"/>
+              <a:t>Transition: advance to Thank You — open Q&A.</a:t>
+            </a:r>
+            <a:endParaRPr lang="en-US" dirty="0"/>
+          </a:p>
+          
+        
+        </p:txBody>
+        
+      
+      </p:sp>
+      
+      
+      <p:sp>
+        
+        
+        <p:nvSpPr>
+          
+          
+          <p:cNvPr id="4" name="Slide Number Placeholder 3"/>
+          
+          
+          <p:cNvSpPr>
+            
+            
+            <a:spLocks noGrp="1"/>
+            
+          
+          </p:cNvSpPr>
+          
+          
+          <p:nvPr>
+            
+            
+            <p:ph type="sldNum" sz="quarter" idx="10"/>
+            
+          
+          </p:nvPr>
+          
+        
+        </p:nvSpPr>
+        
+        
+        <p:spPr/>
+        
+        
+        <p:txBody>
+          
+          
+          <a:bodyPr/>
+          
+          
+          <a:lstStyle/>
+          
+          
+          <a:p>
+            
+            
+            <a:fld id="{F7021451-1387-4CA6-816F-3879F97B5CBC}" type="slidenum">
+              
+              
+              <a:rPr lang="en-US"/>
+              
+              
+              <a:t>17</a:t>
+              
+            
+            </a:fld>
+            
+            
+            <a:endParaRPr lang="en-US"/>
+            
+          
+          </a:p>
+          
+        
+        </p:txBody>
+        
+      
+      </p:sp>
+      
+    
+    </p:spTree>
+    
+    
+    <p:extLst>
+      
+      
+      <p:ext uri="{BB962C8B-B14F-4D97-AF65-F5344CB8AC3E}">
+        
+        
+        <p14:creationId xmlns:p14="http://schemas.microsoft.com/office/powerpoint/2010/main" val="1024086991"/>
+        
+      
+      </p:ext>
+      
+    
+    </p:extLst>
+    
+  
+  </p:cSld>
+  
+  
+  <p:clrMapOvr>
+    
+    
+    <a:masterClrMapping/>
+    
+  
+  </p:clrMapOvr>
+  
+
+</p:notes>
+
 </file>
 
 <file path=ppt/notesSlides/notesSlide2.xml><?xml version="1.0" encoding="utf-8"?>
@@ -9918,6 +10235,3720 @@
     <a:masterClrMapping/>
   </p:clrMapOvr>
 </p:sld>
+</file>
+
+<file path=ppt/slides/slide17.xml><?xml version="1.0" encoding="utf-8"?>
+<p:sld xmlns:a="http://schemas.openxmlformats.org/drawingml/2006/main" xmlns:r="http://schemas.openxmlformats.org/officeDocument/2006/relationships" xmlns:p="http://schemas.openxmlformats.org/presentationml/2006/main">
+  <p:cSld name="Slide 17">
+    <p:bg>
+      <p:bgPr>
+        <a:solidFill>
+          <a:srgbClr val="F0F7FA"/>
+        </a:solidFill>
+      </p:bgPr>
+    </p:bg>
+    <p:spTree>
+      <p:nvGrpSpPr>
+        <p:cNvPr id="1" name=""/>
+        <p:cNvGrpSpPr/>
+        <p:nvPr/>
+      </p:nvGrpSpPr>
+      <p:grpSpPr>
+        <a:xfrm>
+          <a:off x="0" y="0"/>
+          <a:ext cx="0" cy="0"/>
+          <a:chOff x="0" y="0"/>
+          <a:chExt cx="0" cy="0"/>
+        </a:xfrm>
+      </p:grpSpPr>
+      <p:sp>
+        <p:nvSpPr>
+          <p:cNvPr id="2" name="Shape 0"/>
+          <p:cNvSpPr/>
+          <p:nvPr/>
+        </p:nvSpPr>
+        <p:spPr>
+          <a:xfrm>
+            <a:off x="0" y="0"/>
+            <a:ext cx="9144000" cy="960120"/>
+          </a:xfrm>
+          <a:prstGeom prst="rect">
+            <a:avLst/>
+          </a:prstGeom>
+          <a:solidFill>
+            <a:srgbClr val="065A82"/>
+          </a:solidFill>
+          <a:ln/>
+        </p:spPr>
+      </p:sp>
+      <p:sp>
+        <p:nvSpPr>
+          <p:cNvPr id="3" name="Shape 1"/>
+          <p:cNvSpPr/>
+          <p:nvPr/>
+        </p:nvSpPr>
+        <p:spPr>
+          <a:xfrm>
+            <a:off x="0" y="960120"/>
+            <a:ext cx="9144000" cy="54864"/>
+          </a:xfrm>
+          <a:prstGeom prst="rect">
+            <a:avLst/>
+          </a:prstGeom>
+          <a:solidFill>
+            <a:srgbClr val="02C39A"/>
+          </a:solidFill>
+          <a:ln/>
+        </p:spPr>
+      </p:sp>
+      <p:sp>
+        <p:nvSpPr>
+          <p:cNvPr id="4" name="Text 2"/>
+          <p:cNvSpPr/>
+          <p:nvPr/>
+        </p:nvSpPr>
+        <p:spPr>
+          <a:xfrm>
+            <a:off x="457200" y="164592"/>
+            <a:ext cx="8229600" cy="502920"/>
+          </a:xfrm>
+          <a:prstGeom prst="rect">
+            <a:avLst/>
+          </a:prstGeom>
+          <a:noFill/>
+          <a:ln/>
+        </p:spPr>
+        <p:txBody>
+          <a:bodyPr wrap="square" lIns="0" tIns="0" rIns="0" bIns="0" rtlCol="0" anchor="ctr"/>
+          <a:lstStyle/>
+          <a:p>
+            <a:pPr indent="0" marL="0">
+              <a:buNone/>
+            </a:pPr>
+            <a:r>
+              <a:rPr lang="en-US" sz="2800" b="1" dirty="0">
+                <a:solidFill>
+                  <a:srgbClr val="FFFFFF"/>
+                </a:solidFill>
+                <a:latin typeface="Arial" pitchFamily="34" charset="0"/>
+                <a:ea typeface="Arial" pitchFamily="34" charset="-122"/>
+                <a:cs typeface="Arial" pitchFamily="34" charset="-120"/>
+              </a:rPr>
+              <a:t>Problem Overview</a:t>
+            </a:r>
+            <a:endParaRPr lang="en-US" sz="2800" dirty="0"/>
+          </a:p>
+        </p:txBody>
+      </p:sp>
+      <p:sp>
+        <p:nvSpPr>
+          <p:cNvPr id="5" name="Text 3"/>
+          <p:cNvSpPr/>
+          <p:nvPr/>
+        </p:nvSpPr>
+        <p:spPr>
+          <a:xfrm>
+            <a:off x="457200" y="621792"/>
+            <a:ext cx="8229600" cy="274320"/>
+          </a:xfrm>
+          <a:prstGeom prst="rect">
+            <a:avLst/>
+          </a:prstGeom>
+          <a:noFill/>
+          <a:ln/>
+        </p:spPr>
+        <p:txBody>
+          <a:bodyPr wrap="square" lIns="0" tIns="0" rIns="0" bIns="0" rtlCol="0" anchor="ctr"/>
+          <a:lstStyle/>
+          <a:p>
+            <a:pPr indent="0" marL="0">
+              <a:buNone/>
+            </a:pPr>
+            <a:r>
+              <a:rPr lang="en-US" sz="1200" dirty="0">
+                <a:solidFill>
+                  <a:srgbClr val="CADCFC"/>
+                </a:solidFill>
+                <a:latin typeface="Arial" pitchFamily="34" charset="0"/>
+                <a:ea typeface="Arial" pitchFamily="34" charset="-122"/>
+                <a:cs typeface="Arial" pitchFamily="34" charset="-120"/>
+              </a:rPr>
+              <a:t>Three gaps blocking prediction markets from real financial infrastructure · ~30–60 sec</a:t>
+            </a:r>
+            <a:endParaRPr lang="en-US" sz="1200" dirty="0"/>
+          </a:p>
+        </p:txBody>
+      </p:sp>
+      <p:sp>
+        <p:nvSpPr>
+          <p:cNvPr id="6" name="Shape 4"/>
+          <p:cNvSpPr/>
+          <p:nvPr/>
+        </p:nvSpPr>
+        <p:spPr>
+          <a:xfrm>
+            <a:off x="365760" y="1234440"/>
+            <a:ext cx="73152" cy="914400"/>
+          </a:xfrm>
+          <a:prstGeom prst="rect">
+            <a:avLst/>
+          </a:prstGeom>
+          <a:solidFill>
+            <a:srgbClr val="F96167"/>
+          </a:solidFill>
+          <a:ln/>
+        </p:spPr>
+      </p:sp>
+      <p:sp>
+        <p:nvSpPr>
+          <p:cNvPr id="7" name="Text 5"/>
+          <p:cNvSpPr/>
+          <p:nvPr/>
+        </p:nvSpPr>
+        <p:spPr>
+          <a:xfrm>
+            <a:off x="594360" y="1280160"/>
+            <a:ext cx="8046720" cy="320040"/>
+          </a:xfrm>
+          <a:prstGeom prst="rect">
+            <a:avLst/>
+          </a:prstGeom>
+          <a:noFill/>
+          <a:ln/>
+        </p:spPr>
+        <p:txBody>
+          <a:bodyPr wrap="square" lIns="0" tIns="0" rIns="0" bIns="0" rtlCol="0" anchor="ctr"/>
+          <a:lstStyle/>
+          <a:p>
+            <a:pPr indent="0" marL="0">
+              <a:buNone/>
+            </a:pPr>
+            <a:r>
+              <a:rPr lang="en-US" sz="1400" b="1" dirty="0">
+                <a:solidFill>
+                  <a:srgbClr val="065A82"/>
+                </a:solidFill>
+                <a:latin typeface="Arial" pitchFamily="34" charset="0"/>
+                <a:ea typeface="Arial" pitchFamily="34" charset="-122"/>
+                <a:cs typeface="Arial" pitchFamily="34" charset="-120"/>
+              </a:rPr>
+              <a:t>Binary fragmentation — can't express continuous probability</a:t>
+            </a:r>
+            <a:endParaRPr lang="en-US" sz="1400" dirty="0"/>
+          </a:p>
+        </p:txBody>
+      </p:sp>
+      <p:sp>
+        <p:nvSpPr>
+          <p:cNvPr id="8" name="Text 6"/>
+          <p:cNvSpPr/>
+          <p:nvPr/>
+        </p:nvSpPr>
+        <p:spPr>
+          <a:xfrm>
+            <a:off x="594360" y="1618488"/>
+            <a:ext cx="8046720" cy="502920"/>
+          </a:xfrm>
+          <a:prstGeom prst="rect">
+            <a:avLst/>
+          </a:prstGeom>
+          <a:noFill/>
+          <a:ln/>
+        </p:spPr>
+        <p:txBody>
+          <a:bodyPr wrap="square" lIns="0" tIns="0" rIns="0" bIns="0" rtlCol="0" anchor="ctr"/>
+          <a:lstStyle/>
+          <a:p>
+            <a:pPr indent="0" marL="0">
+              <a:buNone/>
+            </a:pPr>
+            <a:r>
+              <a:rPr lang="en-US" sz="1100" dirty="0">
+                <a:solidFill>
+                  <a:srgbClr val="1E293B"/>
+                </a:solidFill>
+                <a:latin typeface="Arial" pitchFamily="34" charset="0"/>
+                <a:ea typeface="Arial" pitchFamily="34" charset="-122"/>
+                <a:cs typeface="Arial" pitchFamily="34" charset="-120"/>
+              </a:rPr>
+              <a:t>Yes/No tokens can't price CPI ranges, vote shares, or goal counts — institutions can't hedge interval risk</a:t>
+            </a:r>
+            <a:endParaRPr lang="en-US" sz="1100" dirty="0"/>
+          </a:p>
+        </p:txBody>
+      </p:sp>
+      <p:sp>
+        <p:nvSpPr>
+          <p:cNvPr id="9" name="Shape 7"/>
+          <p:cNvSpPr/>
+          <p:nvPr/>
+        </p:nvSpPr>
+        <p:spPr>
+          <a:xfrm>
+            <a:off x="365760" y="2377440"/>
+            <a:ext cx="73152" cy="914400"/>
+          </a:xfrm>
+          <a:prstGeom prst="rect">
+            <a:avLst/>
+          </a:prstGeom>
+          <a:solidFill>
+            <a:srgbClr val="F96167"/>
+          </a:solidFill>
+          <a:ln/>
+        </p:spPr>
+      </p:sp>
+      <p:sp>
+        <p:nvSpPr>
+          <p:cNvPr id="10" name="Text 8"/>
+          <p:cNvSpPr/>
+          <p:nvPr/>
+        </p:nvSpPr>
+        <p:spPr>
+          <a:xfrm>
+            <a:off x="594360" y="2423160"/>
+            <a:ext cx="8046720" cy="320040"/>
+          </a:xfrm>
+          <a:prstGeom prst="rect">
+            <a:avLst/>
+          </a:prstGeom>
+          <a:noFill/>
+          <a:ln/>
+        </p:spPr>
+        <p:txBody>
+          <a:bodyPr wrap="square" lIns="0" tIns="0" rIns="0" bIns="0" rtlCol="0" anchor="ctr"/>
+          <a:lstStyle/>
+          <a:p>
+            <a:pPr indent="0" marL="0">
+              <a:buNone/>
+            </a:pPr>
+            <a:r>
+              <a:rPr lang="en-US" sz="1400" b="1" dirty="0">
+                <a:solidFill>
+                  <a:srgbClr val="065A82"/>
+                </a:solidFill>
+                <a:latin typeface="Arial" pitchFamily="34" charset="0"/>
+                <a:ea typeface="Arial" pitchFamily="34" charset="-122"/>
+                <a:cs typeface="Arial" pitchFamily="34" charset="-120"/>
+              </a:rPr>
+              <a:t>Unaudited signal-selling — KOL track records are forgeable</a:t>
+            </a:r>
+            <a:endParaRPr lang="en-US" sz="1400" dirty="0"/>
+          </a:p>
+        </p:txBody>
+      </p:sp>
+      <p:sp>
+        <p:nvSpPr>
+          <p:cNvPr id="11" name="Text 9"/>
+          <p:cNvSpPr/>
+          <p:nvPr/>
+        </p:nvSpPr>
+        <p:spPr>
+          <a:xfrm>
+            <a:off x="594360" y="2761488"/>
+            <a:ext cx="8046720" cy="502920"/>
+          </a:xfrm>
+          <a:prstGeom prst="rect">
+            <a:avLst/>
+          </a:prstGeom>
+          <a:noFill/>
+          <a:ln/>
+        </p:spPr>
+        <p:txBody>
+          <a:bodyPr wrap="square" lIns="0" tIns="0" rIns="0" bIns="0" rtlCol="0" anchor="ctr"/>
+          <a:lstStyle/>
+          <a:p>
+            <a:pPr indent="0" marL="0">
+              <a:buNone/>
+            </a:pPr>
+            <a:r>
+              <a:rPr lang="en-US" sz="1100" dirty="0">
+                <a:solidFill>
+                  <a:srgbClr val="1E293B"/>
+                </a:solidFill>
+                <a:latin typeface="Arial" pitchFamily="34" charset="0"/>
+                <a:ea typeface="Arial" pitchFamily="34" charset="-122"/>
+                <a:cs typeface="Arial" pitchFamily="34" charset="-120"/>
+              </a:rPr>
+              <a:t>Paid KOL track records are forgeable — subscribers can't verify signals after the fact</a:t>
+            </a:r>
+            <a:endParaRPr lang="en-US" sz="1100" dirty="0"/>
+          </a:p>
+        </p:txBody>
+      </p:sp>
+      <p:sp>
+        <p:nvSpPr>
+          <p:cNvPr id="12" name="Shape 10"/>
+          <p:cNvSpPr/>
+          <p:nvPr/>
+        </p:nvSpPr>
+        <p:spPr>
+          <a:xfrm>
+            <a:off x="365760" y="3520440"/>
+            <a:ext cx="73152" cy="914400"/>
+          </a:xfrm>
+          <a:prstGeom prst="rect">
+            <a:avLst/>
+          </a:prstGeom>
+          <a:solidFill>
+            <a:srgbClr val="F96167"/>
+          </a:solidFill>
+          <a:ln/>
+        </p:spPr>
+      </p:sp>
+      <p:sp>
+        <p:nvSpPr>
+          <p:cNvPr id="13" name="Text 11"/>
+          <p:cNvSpPr/>
+          <p:nvPr/>
+        </p:nvSpPr>
+        <p:spPr>
+          <a:xfrm>
+            <a:off x="594360" y="3566160"/>
+            <a:ext cx="8046720" cy="320040"/>
+          </a:xfrm>
+          <a:prstGeom prst="rect">
+            <a:avLst/>
+          </a:prstGeom>
+          <a:noFill/>
+          <a:ln/>
+        </p:spPr>
+        <p:txBody>
+          <a:bodyPr wrap="square" lIns="0" tIns="0" rIns="0" bIns="0" rtlCol="0" anchor="ctr"/>
+          <a:lstStyle/>
+          <a:p>
+            <a:pPr indent="0" marL="0">
+              <a:buNone/>
+            </a:pPr>
+            <a:r>
+              <a:rPr lang="en-US" sz="1400" b="1" dirty="0">
+                <a:solidFill>
+                  <a:srgbClr val="065A82"/>
+                </a:solidFill>
+                <a:latin typeface="Arial" pitchFamily="34" charset="0"/>
+                <a:ea typeface="Arial" pitchFamily="34" charset="-122"/>
+                <a:cs typeface="Arial" pitchFamily="34" charset="-120"/>
+              </a:rPr>
+              <a:t>Split settlement — trading &amp; insights lack one truth source</a:t>
+            </a:r>
+            <a:endParaRPr lang="en-US" sz="1400" dirty="0"/>
+          </a:p>
+        </p:txBody>
+      </p:sp>
+      <p:sp>
+        <p:nvSpPr>
+          <p:cNvPr id="14" name="Text 12"/>
+          <p:cNvSpPr/>
+          <p:nvPr/>
+        </p:nvSpPr>
+        <p:spPr>
+          <a:xfrm>
+            <a:off x="594360" y="3904488"/>
+            <a:ext cx="8046720" cy="502920"/>
+          </a:xfrm>
+          <a:prstGeom prst="rect">
+            <a:avLst/>
+          </a:prstGeom>
+          <a:noFill/>
+          <a:ln/>
+        </p:spPr>
+        <p:txBody>
+          <a:bodyPr wrap="square" lIns="0" tIns="0" rIns="0" bIns="0" rtlCol="0" anchor="ctr"/>
+          <a:lstStyle/>
+          <a:p>
+            <a:pPr indent="0" marL="0">
+              <a:buNone/>
+            </a:pPr>
+            <a:r>
+              <a:rPr lang="en-US" sz="1100" dirty="0">
+                <a:solidFill>
+                  <a:srgbClr val="1E293B"/>
+                </a:solidFill>
+                <a:latin typeface="Arial" pitchFamily="34" charset="0"/>
+                <a:ea typeface="Arial" pitchFamily="34" charset="-122"/>
+                <a:cs typeface="Arial" pitchFamily="34" charset="-120"/>
+              </a:rPr>
+              <a:t>Betting outcomes and paid analysis use different Oracles — one event can't aggregate on a single root</a:t>
+            </a:r>
+            <a:endParaRPr lang="en-US" sz="1100" dirty="0"/>
+          </a:p>
+        </p:txBody>
+      </p:sp>
+      <p:sp>
+        <p:nvSpPr>
+          <p:cNvPr id="15" name="Shape 13"/>
+          <p:cNvSpPr/>
+          <p:nvPr/>
+        </p:nvSpPr>
+        <p:spPr>
+          <a:xfrm>
+            <a:off x="365760" y="4663440"/>
+            <a:ext cx="73152" cy="914400"/>
+          </a:xfrm>
+          <a:prstGeom prst="rect">
+            <a:avLst/>
+          </a:prstGeom>
+          <a:solidFill>
+            <a:srgbClr val="F96167">
+              <a:alpha val="0"/>
+            </a:srgbClr>
+          </a:solidFill>
+          <a:ln/>
+        </p:spPr>
+      </p:sp>
+      <p:sp>
+        <p:nvSpPr>
+          <p:cNvPr id="16" name="Text 14"/>
+          <p:cNvSpPr/>
+          <p:nvPr/>
+        </p:nvSpPr>
+        <p:spPr>
+          <a:xfrm>
+            <a:off x="594360" y="4709160"/>
+            <a:ext cx="8046720" cy="320040"/>
+          </a:xfrm>
+          <a:prstGeom prst="rect">
+            <a:avLst/>
+          </a:prstGeom>
+          <a:noFill/>
+          <a:ln/>
+        </p:spPr>
+        <p:txBody>
+          <a:bodyPr wrap="square" lIns="0" tIns="0" rIns="0" bIns="0" rtlCol="0" anchor="ctr"/>
+          <a:lstStyle/>
+          <a:p>
+            <a:pPr indent="0" marL="0">
+              <a:buNone/>
+            </a:pPr>
+            <a:r>
+              <a:rPr lang="en-US" sz="1400" b="1" dirty="0">
+                <a:solidFill>
+                  <a:srgbClr val="065A82"/>
+                </a:solidFill>
+                <a:latin typeface="Arial" pitchFamily="34" charset="0"/>
+                <a:ea typeface="Arial" pitchFamily="34" charset="-122"/>
+                <a:cs typeface="Arial" pitchFamily="34" charset="-120"/>
+              </a:rPr>
+              <a:t/>
+            </a:r>
+            <a:endParaRPr lang="en-US" sz="1400" dirty="0"/>
+          </a:p>
+        </p:txBody>
+      </p:sp>
+      <p:sp>
+        <p:nvSpPr>
+          <p:cNvPr id="17" name="Text 15"/>
+          <p:cNvSpPr/>
+          <p:nvPr/>
+        </p:nvSpPr>
+        <p:spPr>
+          <a:xfrm>
+            <a:off x="594360" y="5047488"/>
+            <a:ext cx="8046720" cy="502920"/>
+          </a:xfrm>
+          <a:prstGeom prst="rect">
+            <a:avLst/>
+          </a:prstGeom>
+          <a:noFill/>
+          <a:ln/>
+        </p:spPr>
+        <p:txBody>
+          <a:bodyPr wrap="square" lIns="0" tIns="0" rIns="0" bIns="0" rtlCol="0" anchor="ctr"/>
+          <a:lstStyle/>
+          <a:p>
+            <a:pPr indent="0" marL="0">
+              <a:buNone/>
+            </a:pPr>
+            <a:r>
+              <a:rPr lang="en-US" sz="1100" dirty="0">
+                <a:solidFill>
+                  <a:srgbClr val="1E293B"/>
+                </a:solidFill>
+                <a:latin typeface="Arial" pitchFamily="34" charset="0"/>
+                <a:ea typeface="Arial" pitchFamily="34" charset="-122"/>
+                <a:cs typeface="Arial" pitchFamily="34" charset="-120"/>
+              </a:rPr>
+              <a:t/>
+            </a:r>
+            <a:endParaRPr lang="en-US" sz="1100" dirty="0"/>
+          </a:p>
+        </p:txBody>
+      </p:sp>
+      <p:sp>
+        <p:nvSpPr>
+          <p:cNvPr id="18" name="Shape 16"/>
+          <p:cNvSpPr/>
+          <p:nvPr/>
+        </p:nvSpPr>
+        <p:spPr>
+          <a:xfrm>
+            <a:off x="365760" y="4434840"/>
+            <a:ext cx="8412480" cy="502920"/>
+          </a:xfrm>
+          <a:prstGeom prst="rect">
+            <a:avLst/>
+          </a:prstGeom>
+          <a:solidFill>
+            <a:srgbClr val="21295C"/>
+          </a:solidFill>
+          <a:ln/>
+        </p:spPr>
+      </p:sp>
+      <p:sp>
+        <p:nvSpPr>
+          <p:cNvPr id="19" name="Text 17"/>
+          <p:cNvSpPr/>
+          <p:nvPr/>
+        </p:nvSpPr>
+        <p:spPr>
+          <a:xfrm>
+            <a:off x="502920" y="4526280"/>
+            <a:ext cx="8138160" cy="365760"/>
+          </a:xfrm>
+          <a:prstGeom prst="rect">
+            <a:avLst/>
+          </a:prstGeom>
+          <a:noFill/>
+          <a:ln/>
+        </p:spPr>
+        <p:txBody>
+          <a:bodyPr wrap="square" lIns="0" tIns="0" rIns="0" bIns="0" rtlCol="0" anchor="ctr"/>
+          <a:lstStyle/>
+          <a:p>
+            <a:pPr indent="0" marL="0">
+              <a:buNone/>
+            </a:pPr>
+            <a:r>
+              <a:rPr lang="en-US" sz="1100" b="1" dirty="0">
+                <a:solidFill>
+                  <a:srgbClr val="02C39A"/>
+                </a:solidFill>
+                <a:latin typeface="Arial" pitchFamily="34" charset="0"/>
+                <a:ea typeface="Arial" pitchFamily="34" charset="-122"/>
+                <a:cs typeface="Arial" pitchFamily="34" charset="-120"/>
+              </a:rPr>
+              <a:t>Video hook: prediction markets must evolve from outcome gambling to probability distribution derivatives — X-Market rebuilds this on Sui</a:t>
+            </a:r>
+            <a:endParaRPr lang="en-US" sz="1100" dirty="0"/>
+          </a:p>
+        </p:txBody>
+      </p:sp>
+    </p:spTree>
+  </p:cSld>
+  <p:clrMapOvr>
+    <a:masterClrMapping/>
+  </p:clrMapOvr>
+</p:sld>
+</file>
+
+<file path=ppt/slides/slide18.xml><?xml version="1.0" encoding="utf-8"?>
+<p:sld xmlns:a="http://schemas.openxmlformats.org/drawingml/2006/main" xmlns:r="http://schemas.openxmlformats.org/officeDocument/2006/relationships" xmlns:p="http://schemas.openxmlformats.org/presentationml/2006/main">
+  
+  
+  <p:cSld name="Slide 13">
+    
+    
+    <p:bg>
+      
+      
+      <p:bgPr>
+        
+        
+        <a:solidFill>
+          
+          
+          <a:srgbClr val="F0F7FA"/>
+          
+        
+        </a:solidFill>
+        
+      
+      </p:bgPr>
+      
+    
+    </p:bg>
+    
+    
+    <p:spTree>
+      
+      
+      <p:nvGrpSpPr>
+        
+        
+        <p:cNvPr id="1" name=""/>
+        
+        
+        <p:cNvGrpSpPr/>
+        
+        
+        <p:nvPr/>
+        
+      
+      </p:nvGrpSpPr>
+      
+      
+      <p:grpSpPr>
+        
+        
+        <a:xfrm>
+          
+          
+          <a:off x="0" y="0"/>
+          
+          
+          <a:ext cx="0" cy="0"/>
+          
+          
+          <a:chOff x="0" y="0"/>
+          
+          
+          <a:chExt cx="0" cy="0"/>
+          
+        
+        </a:xfrm>
+        
+      
+      </p:grpSpPr>
+      
+      
+      <p:sp>
+        
+        
+        <p:nvSpPr>
+          
+          
+          <p:cNvPr id="2" name="Shape 0"/>
+          
+          
+          <p:cNvSpPr/>
+          
+          
+          <p:nvPr/>
+          
+        
+        </p:nvSpPr>
+        
+        
+        <p:spPr>
+          
+          
+          <a:xfrm>
+            
+            
+            <a:off x="0" y="0"/>
+            
+            
+            <a:ext cx="9144000" cy="960120"/>
+            
+          
+          </a:xfrm>
+          
+          
+          <a:prstGeom prst="rect">
+            
+            
+            <a:avLst/>
+            
+          
+          </a:prstGeom>
+          
+          
+          <a:solidFill>
+            
+            
+            <a:srgbClr val="065A82"/>
+            
+          
+          </a:solidFill>
+          
+          
+          <a:ln/>
+          
+        
+        </p:spPr>
+        
+      
+      </p:sp>
+      
+      
+      <p:sp>
+        
+        
+        <p:nvSpPr>
+          
+          
+          <p:cNvPr id="3" name="Shape 1"/>
+          
+          
+          <p:cNvSpPr/>
+          
+          
+          <p:nvPr/>
+          
+        
+        </p:nvSpPr>
+        
+        
+        <p:spPr>
+          
+          
+          <a:xfrm>
+            
+            
+            <a:off x="0" y="960120"/>
+            
+            
+            <a:ext cx="9144000" cy="54864"/>
+            
+          
+          </a:xfrm>
+          
+          
+          <a:prstGeom prst="rect">
+            
+            
+            <a:avLst/>
+            
+          
+          </a:prstGeom>
+          
+          
+          <a:solidFill>
+            
+            
+            <a:srgbClr val="02C39A"/>
+            
+          
+          </a:solidFill>
+          
+          
+          <a:ln/>
+          
+        
+        </p:spPr>
+        
+      
+      </p:sp>
+      
+      
+      <p:sp>
+        
+        
+        <p:nvSpPr>
+          
+          
+          <p:cNvPr id="4" name="Text 2"/>
+          
+          
+          <p:cNvSpPr/>
+          
+          
+          <p:nvPr/>
+          
+        
+        </p:nvSpPr>
+        
+        
+        <p:spPr>
+          
+          
+          <a:xfrm>
+            
+            
+            <a:off x="457200" y="164592"/>
+            
+            
+            <a:ext cx="8229600" cy="502920"/>
+            
+          
+          </a:xfrm>
+          
+          
+          <a:prstGeom prst="rect">
+            
+            
+            <a:avLst/>
+            
+          
+          </a:prstGeom>
+          
+          
+          <a:noFill/>
+          
+          
+          <a:ln/>
+          
+        
+        </p:spPr>
+        
+        
+        <p:txBody>
+          
+          
+          <a:bodyPr wrap="square" lIns="0" tIns="0" rIns="0" bIns="0" rtlCol="0" anchor="ctr"/>
+          
+          
+          <a:lstStyle/>
+          
+          
+          <a:p>
+            
+            
+            <a:pPr indent="0" marL="0">
+              
+              
+              <a:buNone/>
+              
+            
+            </a:pPr>
+            
+            
+            <a:r>
+              
+              
+              <a:rPr lang="en-US" sz="2800" b="1" dirty="0">
+                
+                
+                <a:solidFill>
+                  
+                  
+                  <a:srgbClr val="FFFFFF"/>
+                  
+                
+                </a:solidFill>
+                
+                
+                <a:latin typeface="Arial" pitchFamily="34" charset="0"/>
+                
+                
+                <a:ea typeface="Arial" pitchFamily="34" charset="-122"/>
+                
+                
+                <a:cs typeface="Arial" pitchFamily="34" charset="-120"/>
+                
+              
+              </a:rPr>
+              
+              
+              <a:t>Conclusion & Future</a:t>
+              
+            
+            </a:r>
+            
+            
+            <a:endParaRPr lang="en-US" sz="2800" dirty="0"/>
+            
+          
+          </a:p>
+          
+        
+        </p:txBody>
+        
+      
+      </p:sp>
+      
+      
+      <p:sp>
+        
+        
+        <p:nvSpPr>
+          
+          
+          <p:cNvPr id="5" name="Text 3"/>
+          
+          
+          <p:cNvSpPr/>
+          
+          
+          <p:nvPr/>
+          
+        
+        </p:nvSpPr>
+        
+        
+        <p:spPr>
+          
+          
+          <a:xfrm>
+            
+            
+            <a:off x="457200" y="621792"/>
+            
+            
+            <a:ext cx="8229600" cy="274320"/>
+            
+          
+          </a:xfrm>
+          
+          
+          <a:prstGeom prst="rect">
+            
+            
+            <a:avLst/>
+            
+          
+          </a:prstGeom>
+          
+          
+          <a:noFill/>
+          
+          
+          <a:ln/>
+          
+        
+        </p:spPr>
+        
+        
+        <p:txBody>
+          
+          
+          <a:bodyPr wrap="square" lIns="0" tIns="0" rIns="0" bIns="0" rtlCol="0" anchor="ctr"/>
+          
+          
+          <a:lstStyle/>
+          
+          
+          <a:p>
+            
+            
+            <a:pPr indent="0" marL="0">
+              
+              
+              <a:buNone/>
+              
+            
+            </a:pPr>
+            
+            
+            <a:r>
+              
+              
+              <a:rPr lang="en-US" sz="1200" dirty="0">
+                
+                
+                <a:solidFill>
+                  
+                  
+                  <a:srgbClr val="CADCFC"/>
+                  
+                
+                </a:solidFill>
+                
+                
+                <a:latin typeface="Arial" pitchFamily="34" charset="0"/>
+                
+                
+                <a:ea typeface="Arial" pitchFamily="34" charset="-122"/>
+                
+                
+                <a:cs typeface="Arial" pitchFamily="34" charset="-120"/>
+                
+              
+              </a:rPr>
+              
+              
+              <a:t>From Testnet validation to mainnet infrastructure · ~60–90 sec</a:t>
+              
+            
+            </a:r>
+            
+            
+            <a:endParaRPr lang="en-US" sz="1200" dirty="0"/>
+            
+          
+          </a:p>
+          
+        
+        </p:txBody>
+        
+      
+      </p:sp>
+      
+      
+      <p:sp>
+        
+        
+        <p:nvSpPr>
+          
+          
+          <p:cNvPr id="6" name="Shape 4"/>
+          
+          
+          <p:cNvSpPr/>
+          
+          
+          <p:nvPr/>
+          
+        
+        </p:nvSpPr>
+        
+        
+        <p:spPr>
+          
+          
+          <a:xfrm>
+            
+            
+            <a:off x="365760" y="1188720"/>
+            
+            
+            <a:ext cx="4023360" cy="1691640"/>
+            
+          
+          </a:xfrm>
+          
+          
+          <a:prstGeom prst="rect">
+            
+            
+            <a:avLst/>
+            
+          
+          </a:prstGeom>
+          
+          
+          <a:solidFill>
+            
+            
+            <a:srgbClr val="FFFFFF"/>
+            
+          
+          </a:solidFill>
+          
+          
+          <a:ln w="12700">
+            
+            
+            <a:solidFill>
+              
+              
+              <a:srgbClr val="E2E8F0"/>
+              
+            
+            </a:solidFill>
+            
+            
+            <a:prstDash val="solid"/>
+            
+          
+          </a:ln>
+          
+          
+          <a:effectLst>
+            
+             
+            
+            <a:outerShdw sx="100000" sy="100000" kx="0" ky="0" algn="bl" rotWithShape="0" blurRad="50800" dist="25400" dir="8100000">
+              
+               
+              
+              <a:srgbClr val="000000">
+                
+                 
+                
+                <a:alpha val="12000"/>
+                
+              
+              </a:srgbClr>
+              
+               
+            
+            </a:outerShdw>
+            
+          
+          </a:effectLst>
+          
+        
+        </p:spPr>
+        
+      
+      </p:sp>
+      
+      
+      <p:sp>
+        
+        
+        <p:nvSpPr>
+          
+          
+          <p:cNvPr id="7" name="Shape 5"/>
+          
+          
+          <p:cNvSpPr/>
+          
+          
+          <p:nvPr/>
+          
+        
+        </p:nvSpPr>
+        
+        
+        <p:spPr>
+          
+          
+          <a:xfrm>
+            
+            
+            <a:off x="548640" y="1371600"/>
+            
+            
+            <a:ext cx="502920" cy="502920"/>
+            
+          
+          </a:xfrm>
+          
+          
+          <a:prstGeom prst="ellipse">
+            
+            
+            <a:avLst/>
+            
+          
+          </a:prstGeom>
+          
+          
+          <a:solidFill>
+            
+            
+            <a:srgbClr val="02C39A"/>
+            
+          
+          </a:solidFill>
+          
+          
+          <a:ln/>
+          
+        
+        </p:spPr>
+        
+      
+      </p:sp>
+      
+      
+      <p:sp>
+        
+        
+        <p:nvSpPr>
+          
+          
+          <p:cNvPr id="8" name="Text 6"/>
+          
+          
+          <p:cNvSpPr/>
+          
+          
+          <p:nvPr/>
+          
+        
+        </p:nvSpPr>
+        
+        
+        <p:spPr>
+          
+          
+          <a:xfrm>
+            
+            
+            <a:off x="548640" y="1371600"/>
+            
+            
+            <a:ext cx="502920" cy="502920"/>
+            
+          
+          </a:xfrm>
+          
+          
+          <a:prstGeom prst="rect">
+            
+            
+            <a:avLst/>
+            
+          
+          </a:prstGeom>
+          
+          
+          <a:noFill/>
+          
+          
+          <a:ln/>
+          
+        
+        </p:spPr>
+        
+        
+        <p:txBody>
+          
+          
+          <a:bodyPr wrap="square" lIns="0" tIns="0" rIns="0" bIns="0" rtlCol="0" anchor="ctr"/>
+          
+          
+          <a:lstStyle/>
+          
+          
+          <a:p>
+            
+            
+            <a:pPr algn="ctr" indent="0" marL="0">
+              
+              
+              <a:buNone/>
+              
+            
+            </a:pPr>
+            
+            
+            <a:r>
+              
+              
+              <a:rPr lang="en-US" sz="1600" dirty="0">
+                
+                
+                <a:solidFill>
+                  
+                  
+                  <a:srgbClr val="000000"/>
+                  
+                
+                </a:solidFill>
+                
+              
+              </a:rPr>
+              
+              
+              <a:t>✅</a:t>
+              
+            
+            </a:r>
+            
+            
+            <a:endParaRPr lang="en-US" sz="1600" dirty="0"/>
+            
+          
+          </a:p>
+          
+        
+        </p:txBody>
+        
+      
+      </p:sp>
+      
+      
+      <p:sp>
+        
+        
+        <p:nvSpPr>
+          
+          
+          <p:cNvPr id="9" name="Text 7"/>
+          
+          
+          <p:cNvSpPr/>
+          
+          
+          <p:nvPr/>
+          
+        
+        </p:nvSpPr>
+        
+        
+        <p:spPr>
+          
+          
+          <a:xfrm>
+            
+            
+            <a:off x="1143000" y="1353312"/>
+            
+            
+            <a:ext cx="3108960" cy="365760"/>
+            
+          
+          </a:xfrm>
+          
+          
+          <a:prstGeom prst="rect">
+            
+            
+            <a:avLst/>
+            
+          
+          </a:prstGeom>
+          
+          
+          <a:noFill/>
+          
+          
+          <a:ln/>
+          
+        
+        </p:spPr>
+        
+        
+        <p:txBody>
+          
+          
+          <a:bodyPr wrap="square" lIns="0" tIns="0" rIns="0" bIns="0" rtlCol="0" anchor="ctr"/>
+          
+          
+          <a:lstStyle/>
+          
+          
+          <a:p>
+            
+            
+            <a:pPr indent="0" marL="0">
+              
+              
+              <a:buNone/>
+              
+            
+            </a:pPr>
+            
+            
+            <a:r>
+              
+              
+              <a:rPr lang="en-US" sz="1400" b="1" dirty="0">
+                
+                
+                <a:solidFill>
+                  
+                  
+                  <a:srgbClr val="065A82"/>
+                  
+                
+                </a:solidFill>
+                
+                
+                <a:latin typeface="Arial" pitchFamily="34" charset="0"/>
+                
+                
+                <a:ea typeface="Arial" pitchFamily="34" charset="-122"/>
+                
+                
+                <a:cs typeface="Arial" pitchFamily="34" charset="-120"/>
+                
+              
+              </a:rPr>
+              
+              
+              <a:t>Core Conclusions</a:t>
+              
+            
+            </a:r>
+            
+            
+            <a:endParaRPr lang="en-US" sz="1400" dirty="0"/>
+            
+          
+          </a:p>
+          
+        
+        </p:txBody>
+        
+      
+      </p:sp>
+      
+      
+      <p:sp>
+        
+        
+        <p:nvSpPr>
+          
+          
+          <p:cNvPr id="10" name="Text 8"/>
+          
+          
+          <p:cNvSpPr/>
+          
+          
+          <p:nvPr/>
+          
+        
+        </p:nvSpPr>
+        
+        
+        <p:spPr>
+          
+          
+          <a:xfrm>
+            
+            
+            <a:off x="548640" y="1874520"/>
+            
+            
+            <a:ext cx="3657600" cy="914400"/>
+            
+          
+          </a:xfrm>
+          
+          
+          <a:prstGeom prst="rect">
+            
+            
+            <a:avLst/>
+            
+          
+          </a:prstGeom>
+          
+          
+          <a:noFill/>
+          
+          
+          <a:ln/>
+          
+        
+        </p:spPr>
+        
+        
+        <p:txBody>
+          
+          
+          <a:bodyPr wrap="square" rtlCol="0" anchor="t"/>
+          
+          
+          <a:lstStyle/>
+          
+          
+          <a:p>
+            
+            
+            <a:pPr marL="342900" indent="-342900">
+              
+              
+              <a:buSzPct val="100000"/>
+              
+              
+              <a:buChar char="•"/>
+              
+            
+            </a:pPr>
+            
+            
+            <a:r>
+              
+              
+              <a:rPr lang="en-US" sz="1000" dirty="0">
+                
+                
+                <a:solidFill>
+                  
+                  
+                  <a:srgbClr val="1E293B"/>
+                  
+                
+                </a:solidFill>
+                
+                
+                <a:latin typeface="Arial" pitchFamily="34" charset="0"/>
+                
+                
+                <a:ea typeface="Arial" pitchFamily="34" charset="-122"/>
+                
+                
+                <a:cs typeface="Arial" pitchFamily="34" charset="-120"/>
+                
+              
+              </a:rPr>
+              
+              
+              <a:t>Prediction markets must evolve from gambling to PDF probability derivatives</a:t>
+              
+            
+            </a:r>
+            
+            
+            <a:endParaRPr lang="en-US" sz="1000" dirty="0"/>
+            
+          
+          </a:p>
+          
+          
+          <a:p>
+            
+            
+            <a:pPr marL="342900" indent="-342900">
+              
+              
+              <a:buSzPct val="100000"/>
+              
+              
+              <a:buChar char="•"/>
+              
+            
+            </a:pPr>
+            
+            
+            <a:r>
+              
+              
+              <a:rPr lang="en-US" sz="1000" dirty="0">
+                
+                
+                <a:solidFill>
+                  
+                  
+                  <a:srgbClr val="1E293B"/>
+                  
+                
+                </a:solidFill>
+                
+                
+                <a:latin typeface="Arial" pitchFamily="34" charset="0"/>
+                
+                
+                <a:ea typeface="Arial" pitchFamily="34" charset="-122"/>
+                
+                
+                <a:cs typeface="Arial" pitchFamily="34" charset="-120"/>
+                
+              
+              </a:rPr>
+              
+              
+              <a:t>Dual modules share EventRoot · unified Oracle settlement truth</a:t>
+              
+            
+            </a:r>
+            
+            
+            <a:endParaRPr lang="en-US" sz="1000" dirty="0"/>
+            
+          
+          </a:p>
+          
+          
+          <a:p>
+            
+            
+            <a:pPr marL="342900" indent="-342900">
+              
+              
+              <a:buSzPct val="100000"/>
+              
+              
+              <a:buChar char="•"/>
+              
+            
+            </a:pPr>
+            
+            
+            <a:r>
+              
+              
+              <a:rPr lang="en-US" sz="1000" dirty="0">
+                
+                
+                <a:solidFill>
+                  
+                  
+                  <a:srgbClr val="1E293B"/>
+                  
+                
+                </a:solidFill>
+                
+                
+                <a:latin typeface="Arial" pitchFamily="34" charset="0"/>
+                
+                
+                <a:ea typeface="Arial" pitchFamily="34" charset="-122"/>
+                
+                
+                <a:cs typeface="Arial" pitchFamily="34" charset="-120"/>
+                
+              
+              </a:rPr>
+              
+              
+              <a:t>On-chain PDF pricing + Seal forced audit · four-sided win-win ecosystem</a:t>
+              
+            
+            </a:r>
+            
+            
+            <a:endParaRPr lang="en-US" sz="1000" dirty="0"/>
+            
+          
+          </a:p>
+          
+          
+          <a:p>
+            
+            
+            <a:pPr marL="342900" indent="-342900">
+              
+              
+              <a:buSzPct val="100000"/>
+              
+              
+              <a:buChar char="•"/>
+              
+            
+            </a:pPr>
+            
+            
+            <a:r>
+              
+              
+              <a:rPr lang="en-US" sz="1000" dirty="0">
+                
+                
+                <a:solidFill>
+                  
+                  
+                  <a:srgbClr val="1E293B"/>
+                  
+                
+                </a:solidFill>
+                
+                
+                <a:latin typeface="Arial" pitchFamily="34" charset="0"/>
+                
+                
+                <a:ea typeface="Arial" pitchFamily="34" charset="-122"/>
+                
+                
+                <a:cs typeface="Arial" pitchFamily="34" charset="-120"/>
+                
+              
+              </a:rPr>
+              
+              
+              <a:t>Testnet v2 full stack validated — not a concept</a:t>
+              
+            
+            </a:r>
+            
+            
+            <a:endParaRPr lang="en-US" sz="1000" dirty="0"/>
+            
+          
+          </a:p>
+          
+        
+        </p:txBody>
+        
+      
+      </p:sp>
+      
+      
+      <p:sp>
+        
+        
+        <p:nvSpPr>
+          
+          
+          <p:cNvPr id="11" name="Shape 9"/>
+          
+          
+          <p:cNvSpPr/>
+          
+          
+          <p:nvPr/>
+          
+        
+        </p:nvSpPr>
+        
+        
+        <p:spPr>
+          
+          
+          <a:xfrm>
+            
+            
+            <a:off x="4754880" y="1188720"/>
+            
+            
+            <a:ext cx="4023360" cy="1691640"/>
+            
+          
+          </a:xfrm>
+          
+          
+          <a:prstGeom prst="rect">
+            
+            
+            <a:avLst/>
+            
+          
+          </a:prstGeom>
+          
+          
+          <a:solidFill>
+            
+            
+            <a:srgbClr val="FFFFFF"/>
+            
+          
+          </a:solidFill>
+          
+          
+          <a:ln w="12700">
+            
+            
+            <a:solidFill>
+              
+              
+              <a:srgbClr val="E2E8F0"/>
+              
+            
+            </a:solidFill>
+            
+            
+            <a:prstDash val="solid"/>
+            
+          
+          </a:ln>
+          
+          
+          <a:effectLst>
+            
+             
+            
+            <a:outerShdw sx="100000" sy="100000" kx="0" ky="0" algn="bl" rotWithShape="0" blurRad="50800" dist="25400" dir="8100000">
+              
+               
+              
+              <a:srgbClr val="000000">
+                
+                 
+                
+                <a:alpha val="12000"/>
+                
+              
+              </a:srgbClr>
+              
+               
+            
+            </a:outerShdw>
+            
+          
+          </a:effectLst>
+          
+        
+        </p:spPr>
+        
+      
+      </p:sp>
+      
+      
+      <p:sp>
+        
+        
+        <p:nvSpPr>
+          
+          
+          <p:cNvPr id="12" name="Shape 10"/>
+          
+          
+          <p:cNvSpPr/>
+          
+          
+          <p:nvPr/>
+          
+        
+        </p:nvSpPr>
+        
+        
+        <p:spPr>
+          
+          
+          <a:xfrm>
+            
+            
+            <a:off x="4937760" y="1371600"/>
+            
+            
+            <a:ext cx="502920" cy="502920"/>
+            
+          
+          </a:xfrm>
+          
+          
+          <a:prstGeom prst="ellipse">
+            
+            
+            <a:avLst/>
+            
+          
+          </a:prstGeom>
+          
+          
+          <a:solidFill>
+            
+            
+            <a:srgbClr val="1C7293"/>
+            
+          
+          </a:solidFill>
+          
+          
+          <a:ln/>
+          
+        
+        </p:spPr>
+        
+      
+      </p:sp>
+      
+      
+      <p:sp>
+        
+        
+        <p:nvSpPr>
+          
+          
+          <p:cNvPr id="13" name="Text 11"/>
+          
+          
+          <p:cNvSpPr/>
+          
+          
+          <p:nvPr/>
+          
+        
+        </p:nvSpPr>
+        
+        
+        <p:spPr>
+          
+          
+          <a:xfrm>
+            
+            
+            <a:off x="4937760" y="1371600"/>
+            
+            
+            <a:ext cx="502920" cy="502920"/>
+            
+          
+          </a:xfrm>
+          
+          
+          <a:prstGeom prst="rect">
+            
+            
+            <a:avLst/>
+            
+          
+          </a:prstGeom>
+          
+          
+          <a:noFill/>
+          
+          
+          <a:ln/>
+          
+        
+        </p:spPr>
+        
+        
+        <p:txBody>
+          
+          
+          <a:bodyPr wrap="square" lIns="0" tIns="0" rIns="0" bIns="0" rtlCol="0" anchor="ctr"/>
+          
+          
+          <a:lstStyle/>
+          
+          
+          <a:p>
+            
+            
+            <a:pPr algn="ctr" indent="0" marL="0">
+              
+              
+              <a:buNone/>
+              
+            
+            </a:pPr>
+            
+            
+            <a:r>
+              
+              
+              <a:rPr lang="en-US" sz="1600" dirty="0">
+                
+                
+                <a:solidFill>
+                  
+                  
+                  <a:srgbClr val="000000"/>
+                  
+                
+                </a:solidFill>
+                
+              
+              </a:rPr>
+              
+              
+              <a:t>🔬</a:t>
+              
+            
+            </a:r>
+            
+            
+            <a:endParaRPr lang="en-US" sz="1600" dirty="0"/>
+            
+          
+          </a:p>
+          
+        
+        </p:txBody>
+        
+      
+      </p:sp>
+      
+      
+      <p:sp>
+        
+        
+        <p:nvSpPr>
+          
+          
+          <p:cNvPr id="14" name="Text 12"/>
+          
+          
+          <p:cNvSpPr/>
+          
+          
+          <p:nvPr/>
+          
+        
+        </p:nvSpPr>
+        
+        
+        <p:spPr>
+          
+          
+          <a:xfrm>
+            
+            
+            <a:off x="5532120" y="1353312"/>
+            
+            
+            <a:ext cx="3108960" cy="365760"/>
+            
+          
+          </a:xfrm>
+          
+          
+          <a:prstGeom prst="rect">
+            
+            
+            <a:avLst/>
+            
+          
+          </a:prstGeom>
+          
+          
+          <a:noFill/>
+          
+          
+          <a:ln/>
+          
+        
+        </p:spPr>
+        
+        
+        <p:txBody>
+          
+          
+          <a:bodyPr wrap="square" lIns="0" tIns="0" rIns="0" bIns="0" rtlCol="0" anchor="ctr"/>
+          
+          
+          <a:lstStyle/>
+          
+          
+          <a:p>
+            
+            
+            <a:pPr indent="0" marL="0">
+              
+              
+              <a:buNone/>
+              
+            
+            </a:pPr>
+            
+            
+            <a:r>
+              
+              
+              <a:rPr lang="en-US" sz="1400" b="1" dirty="0">
+                
+                
+                <a:solidFill>
+                  
+                  
+                  <a:srgbClr val="065A82"/>
+                  
+                
+                </a:solidFill>
+                
+                
+                <a:latin typeface="Arial" pitchFamily="34" charset="0"/>
+                
+                
+                <a:ea typeface="Arial" pitchFamily="34" charset="-122"/>
+                
+                
+                <a:cs typeface="Arial" pitchFamily="34" charset="-120"/>
+                
+              
+              </a:rPr>
+              
+              
+              <a:t>Validated Capabilities</a:t>
+              
+            
+            </a:r>
+            
+            
+            <a:endParaRPr lang="en-US" sz="1400" dirty="0"/>
+            
+          
+          </a:p>
+          
+        
+        </p:txBody>
+        
+      
+      </p:sp>
+      
+      
+      <p:sp>
+        
+        
+        <p:nvSpPr>
+          
+          
+          <p:cNvPr id="15" name="Text 13"/>
+          
+          
+          <p:cNvSpPr/>
+          
+          
+          <p:nvPr/>
+          
+        
+        </p:nvSpPr>
+        
+        
+        <p:spPr>
+          
+          
+          <a:xfrm>
+            
+            
+            <a:off x="4937760" y="1874520"/>
+            
+            
+            <a:ext cx="3657600" cy="914400"/>
+            
+          
+          </a:xfrm>
+          
+          
+          <a:prstGeom prst="rect">
+            
+            
+            <a:avLst/>
+            
+          
+          </a:prstGeom>
+          
+          
+          <a:noFill/>
+          
+          
+          <a:ln/>
+          
+        
+        </p:spPr>
+        
+        
+        <p:txBody>
+          
+          
+          <a:bodyPr wrap="square" rtlCol="0" anchor="t"/>
+          
+          
+          <a:lstStyle/>
+          
+          
+          <a:p>
+            
+            
+            <a:pPr marL="342900" indent="-342900">
+              
+              
+              <a:buSzPct val="100000"/>
+              
+              
+              <a:buChar char="•"/>
+              
+            
+            </a:pPr>
+            
+            
+            <a:r>
+              
+              
+              <a:rPr lang="en-US" sz="1000" dirty="0">
+                
+                
+                <a:solidFill>
+                  
+                  
+                  <a:srgbClr val="1E293B"/>
+                  
+                
+                </a:solidFill>
+                
+                
+                <a:latin typeface="Arial" pitchFamily="34" charset="0"/>
+                
+                
+                <a:ea typeface="Arial" pitchFamily="34" charset="-122"/>
+                
+                
+                <a:cs typeface="Arial" pitchFamily="34" charset="-120"/>
+                
+              
+              </a:rPr>
+              
+              
+              <a:t>30+ Move modules · three distribution templates deployed</a:t>
+              
+            
+            </a:r>
+            
+            
+            <a:endParaRPr lang="en-US" sz="1000" dirty="0"/>
+            
+          
+          </a:p>
+          
+          
+          <a:p>
+            
+            
+            <a:pPr marL="342900" indent="-342900">
+              
+              
+              <a:buSzPct val="100000"/>
+              
+              
+              <a:buChar char="•"/>
+              
+            
+            </a:pPr>
+            
+            
+            <a:r>
+              
+              
+              <a:rPr lang="en-US" sz="1000" dirty="0">
+                
+                
+                <a:solidFill>
+                  
+                  
+                  <a:srgbClr val="1E293B"/>
+                  
+                
+                </a:solidFill>
+                
+                
+                <a:latin typeface="Arial" pitchFamily="34" charset="0"/>
+                
+                
+                <a:ea typeface="Arial" pitchFamily="34" charset="-122"/>
+                
+                
+                <a:cs typeface="Arial" pitchFamily="34" charset="-120"/>
+                
+              
+              </a:rPr>
+              
+              
+              <a:t>Opening Auction cold start · Max-Loss full-path coverage</a:t>
+              
+            
+            </a:r>
+            
+            
+            <a:endParaRPr lang="en-US" sz="1000" dirty="0"/>
+            
+          
+          </a:p>
+          
+          
+          <a:p>
+            
+            
+            <a:pPr marL="342900" indent="-342900">
+              
+              
+              <a:buSzPct val="100000"/>
+              
+              
+              <a:buChar char="•"/>
+              
+            
+            </a:pPr>
+            
+            
+            <a:r>
+              
+              
+              <a:rPr lang="en-US" sz="1000" dirty="0">
+                
+                
+                <a:solidFill>
+                  
+                  
+                  <a:srgbClr val="1E293B"/>
+                  
+                
+                </a:solidFill>
+                
+                
+                <a:latin typeface="Arial" pitchFamily="34" charset="0"/>
+                
+                
+                <a:ea typeface="Arial" pitchFamily="34" charset="-122"/>
+                
+                
+                <a:cs typeface="Arial" pitchFamily="34" charset="-120"/>
+                
+              
+              </a:rPr>
+              
+              
+              <a:t>SuiProphet + Indexer + Flutter end-to-end integrated</a:t>
+              
+            
+            </a:r>
+            
+            
+            <a:endParaRPr lang="en-US" sz="1000" dirty="0"/>
+            
+          
+          </a:p>
+          
+          
+          <a:p>
+            
+            
+            <a:pPr marL="342900" indent="-342900">
+              
+              
+              <a:buSzPct val="100000"/>
+              
+              
+              <a:buChar char="•"/>
+              
+            
+            </a:pPr>
+            
+            
+            <a:r>
+              
+              
+              <a:rPr lang="en-US" sz="1000" dirty="0">
+                
+                
+                <a:solidFill>
+                  
+                  
+                  <a:srgbClr val="1E293B"/>
+                  
+                
+                </a:solidFill>
+                
+                
+                <a:latin typeface="Arial" pitchFamily="34" charset="0"/>
+                
+                
+                <a:ea typeface="Arial" pitchFamily="34" charset="-122"/>
+                
+                
+                <a:cs typeface="Arial" pitchFamily="34" charset="-120"/>
+                
+              
+              </a:rPr>
+              
+              
+              <a:t>9+ off-chain microservices · Docker orchestration production-ready</a:t>
+              
+            
+            </a:r>
+            
+            
+            <a:endParaRPr lang="en-US" sz="1000" dirty="0"/>
+            
+          
+          </a:p>
+          
+        
+        </p:txBody>
+        
+      
+      </p:sp>
+      
+      
+      <p:sp>
+        
+        
+        <p:nvSpPr>
+          
+          
+          <p:cNvPr id="16" name="Shape 14"/>
+          
+          
+          <p:cNvSpPr/>
+          
+          
+          <p:nvPr/>
+          
+        
+        </p:nvSpPr>
+        
+        
+        <p:spPr>
+          
+          
+          <a:xfrm>
+            
+            
+            <a:off x="365760" y="3063240"/>
+            
+            
+            <a:ext cx="4023360" cy="1691640"/>
+            
+          
+          </a:xfrm>
+          
+          
+          <a:prstGeom prst="rect">
+            
+            
+            <a:avLst/>
+            
+          
+          </a:prstGeom>
+          
+          
+          <a:solidFill>
+            
+            
+            <a:srgbClr val="FFFFFF"/>
+            
+          
+          </a:solidFill>
+          
+          
+          <a:ln w="12700">
+            
+            
+            <a:solidFill>
+              
+              
+              <a:srgbClr val="E2E8F0"/>
+              
+            
+            </a:solidFill>
+            
+            
+            <a:prstDash val="solid"/>
+            
+          
+          </a:ln>
+          
+          
+          <a:effectLst>
+            
+             
+            
+            <a:outerShdw sx="100000" sy="100000" kx="0" ky="0" algn="bl" rotWithShape="0" blurRad="50800" dist="25400" dir="8100000">
+              
+               
+              
+              <a:srgbClr val="000000">
+                
+                 
+                
+                <a:alpha val="12000"/>
+                
+              
+              </a:srgbClr>
+              
+               
+            
+            </a:outerShdw>
+            
+          
+          </a:effectLst>
+          
+        
+        </p:spPr>
+        
+      
+      </p:sp>
+      
+      
+      <p:sp>
+        
+        
+        <p:nvSpPr>
+          
+          
+          <p:cNvPr id="17" name="Shape 15"/>
+          
+          
+          <p:cNvSpPr/>
+          
+          
+          <p:nvPr/>
+          
+        
+        </p:nvSpPr>
+        
+        
+        <p:spPr>
+          
+          
+          <a:xfrm>
+            
+            
+            <a:off x="548640" y="3246120"/>
+            
+            
+            <a:ext cx="502920" cy="502920"/>
+            
+          
+          </a:xfrm>
+          
+          
+          <a:prstGeom prst="ellipse">
+            
+            
+            <a:avLst/>
+            
+          
+          </a:prstGeom>
+          
+          
+          <a:solidFill>
+            
+            
+            <a:srgbClr val="065A82"/>
+            
+          
+          </a:solidFill>
+          
+          
+          <a:ln/>
+          
+        
+        </p:spPr>
+        
+      
+      </p:sp>
+      
+      
+      <p:sp>
+        
+        
+        <p:nvSpPr>
+          
+          
+          <p:cNvPr id="18" name="Text 16"/>
+          
+          
+          <p:cNvSpPr/>
+          
+          
+          <p:nvPr/>
+          
+        
+        </p:nvSpPr>
+        
+        
+        <p:spPr>
+          
+          
+          <a:xfrm>
+            
+            
+            <a:off x="548640" y="3246120"/>
+            
+            
+            <a:ext cx="502920" cy="502920"/>
+            
+          
+          </a:xfrm>
+          
+          
+          <a:prstGeom prst="rect">
+            
+            
+            <a:avLst/>
+            
+          
+          </a:prstGeom>
+          
+          
+          <a:noFill/>
+          
+          
+          <a:ln/>
+          
+        
+        </p:spPr>
+        
+        
+        <p:txBody>
+          
+          
+          <a:bodyPr wrap="square" lIns="0" tIns="0" rIns="0" bIns="0" rtlCol="0" anchor="ctr"/>
+          
+          
+          <a:lstStyle/>
+          
+          
+          <a:p>
+            
+            
+            <a:pPr algn="ctr" indent="0" marL="0">
+              
+              
+              <a:buNone/>
+              
+            
+            </a:pPr>
+            
+            
+            <a:r>
+              
+              
+              <a:rPr lang="en-US" sz="1600" dirty="0">
+                
+                
+                <a:solidFill>
+                  
+                  
+                  <a:srgbClr val="000000"/>
+                  
+                
+                </a:solidFill>
+                
+              
+              </a:rPr>
+              
+              
+              <a:t>🚀</a:t>
+              
+            
+            </a:r>
+            
+            
+            <a:endParaRPr lang="en-US" sz="1600" dirty="0"/>
+            
+          
+          </a:p>
+          
+        
+        </p:txBody>
+        
+      
+      </p:sp>
+      
+      
+      <p:sp>
+        
+        
+        <p:nvSpPr>
+          
+          
+          <p:cNvPr id="19" name="Text 17"/>
+          
+          
+          <p:cNvSpPr/>
+          
+          
+          <p:nvPr/>
+          
+        
+        </p:nvSpPr>
+        
+        
+        <p:spPr>
+          
+          
+          <a:xfrm>
+            
+            
+            <a:off x="1143000" y="3227832"/>
+            
+            
+            <a:ext cx="3108960" cy="365760"/>
+            
+          
+          </a:xfrm>
+          
+          
+          <a:prstGeom prst="rect">
+            
+            
+            <a:avLst/>
+            
+          
+          </a:prstGeom>
+          
+          
+          <a:noFill/>
+          
+          
+          <a:ln/>
+          
+        
+        </p:spPr>
+        
+        
+        <p:txBody>
+          
+          
+          <a:bodyPr wrap="square" lIns="0" tIns="0" rIns="0" bIns="0" rtlCol="0" anchor="ctr"/>
+          
+          
+          <a:lstStyle/>
+          
+          
+          <a:p>
+            
+            
+            <a:pPr indent="0" marL="0">
+              
+              
+              <a:buNone/>
+              
+            
+            </a:pPr>
+            
+            
+            <a:r>
+              
+              
+              <a:rPr lang="en-US" sz="1400" b="1" dirty="0">
+                
+                
+                <a:solidFill>
+                  
+                  
+                  <a:srgbClr val="065A82"/>
+                  
+                
+                </a:solidFill>
+                
+                
+                <a:latin typeface="Arial" pitchFamily="34" charset="0"/>
+                
+                
+                <a:ea typeface="Arial" pitchFamily="34" charset="-122"/>
+                
+                
+                <a:cs typeface="Arial" pitchFamily="34" charset="-120"/>
+                
+              
+              </a:rPr>
+              
+              
+              <a:t>Near-Term Outlook</a:t>
+              
+            
+            </a:r>
+            
+            
+            <a:endParaRPr lang="en-US" sz="1400" dirty="0"/>
+            
+          
+          </a:p>
+          
+        
+        </p:txBody>
+        
+      
+      </p:sp>
+      
+      
+      <p:sp>
+        
+        
+        <p:nvSpPr>
+          
+          
+          <p:cNvPr id="20" name="Text 18"/>
+          
+          
+          <p:cNvSpPr/>
+          
+          
+          <p:nvPr/>
+          
+        
+        </p:nvSpPr>
+        
+        
+        <p:spPr>
+          
+          
+          <a:xfrm>
+            
+            
+            <a:off x="548640" y="3749040"/>
+            
+            
+            <a:ext cx="3657600" cy="914400"/>
+            
+          
+          </a:xfrm>
+          
+          
+          <a:prstGeom prst="rect">
+            
+            
+            <a:avLst/>
+            
+          
+          </a:prstGeom>
+          
+          
+          <a:noFill/>
+          
+          
+          <a:ln/>
+          
+        
+        </p:spPr>
+        
+        
+        <p:txBody>
+          
+          
+          <a:bodyPr wrap="square" rtlCol="0" anchor="t"/>
+          
+          
+          <a:lstStyle/>
+          
+          
+          <a:p>
+            
+            
+            <a:pPr marL="342900" indent="-342900">
+              
+              
+              <a:buSzPct val="100000"/>
+              
+              
+              <a:buChar char="•"/>
+              
+            
+            </a:pPr>
+            
+            
+            <a:r>
+              
+              
+              <a:rPr lang="en-US" sz="1000" dirty="0">
+                
+                
+                <a:solidFill>
+                  
+                  
+                  <a:srgbClr val="1E293B"/>
+                  
+                
+                </a:solidFill>
+                
+                
+                <a:latin typeface="Arial" pitchFamily="34" charset="0"/>
+                
+                
+                <a:ea typeface="Arial" pitchFamily="34" charset="-122"/>
+                
+                
+                <a:cs typeface="Arial" pitchFamily="34" charset="-120"/>
+                
+              
+              </a:rPr>
+              
+              
+              <a:t>Phase 3: Variance Swap · Slash governance · ZK cold-path completion</a:t>
+              
+            
+            </a:r>
+            
+            
+            <a:endParaRPr lang="en-US" sz="1000" dirty="0"/>
+            
+          
+          </a:p>
+          
+          
+          <a:p>
+            
+            
+            <a:pPr marL="342900" indent="-342900">
+              
+              
+              <a:buSzPct val="100000"/>
+              
+              
+              <a:buChar char="•"/>
+              
+            
+            </a:pPr>
+            
+            
+            <a:r>
+              
+              
+              <a:rPr lang="en-US" sz="1000" dirty="0">
+                
+                
+                <a:solidFill>
+                  
+                  
+                  <a:srgbClr val="1E293B"/>
+                  
+                
+                </a:solidFill>
+                
+                
+                <a:latin typeface="Arial" pitchFamily="34" charset="0"/>
+                
+                
+                <a:ea typeface="Arial" pitchFamily="34" charset="-122"/>
+                
+                
+                <a:cs typeface="Arial" pitchFamily="34" charset="-120"/>
+                
+              
+              </a:rPr>
+              
+              
+              <a:t>Beta distribution · dual-pool joint probability · more vertical PDF markets</a:t>
+              
+            
+            </a:r>
+            
+            
+            <a:endParaRPr lang="en-US" sz="1000" dirty="0"/>
+            
+          
+          </a:p>
+          
+          
+          <a:p>
+            
+            
+            <a:pPr marL="342900" indent="-342900">
+              
+              
+              <a:buSzPct val="100000"/>
+              
+              
+              <a:buChar char="•"/>
+              
+            
+            </a:pPr>
+            
+            
+            <a:r>
+              
+              
+              <a:rPr lang="en-US" sz="1000" dirty="0">
+                
+                
+                <a:solidFill>
+                  
+                  
+                  <a:srgbClr val="1E293B"/>
+                  
+                
+                </a:solidFill>
+                
+                
+                <a:latin typeface="Arial" pitchFamily="34" charset="0"/>
+                
+                
+                <a:ea typeface="Arial" pitchFamily="34" charset="-122"/>
+                
+                
+                <a:cs typeface="Arial" pitchFamily="34" charset="-120"/>
+                
+              
+              </a:rPr>
+              
+              
+              <a:t>Attestation + Brevis Prover: mock → live supervision line</a:t>
+              
+            
+            </a:r>
+            
+            
+            <a:endParaRPr lang="en-US" sz="1000" dirty="0"/>
+            
+          
+          </a:p>
+          
+          
+          <a:p>
+            
+            
+            <a:pPr marL="342900" indent="-342900">
+              
+              
+              <a:buSzPct val="100000"/>
+              
+              
+              <a:buChar char="•"/>
+              
+            
+            </a:pPr>
+            
+            
+            <a:r>
+              
+              
+              <a:rPr lang="en-US" sz="1000" dirty="0">
+                
+                
+                <a:solidFill>
+                  
+                  
+                  <a:srgbClr val="1E293B"/>
+                  
+                
+                </a:solidFill>
+                
+                
+                <a:latin typeface="Arial" pitchFamily="34" charset="0"/>
+                
+                
+                <a:ea typeface="Arial" pitchFamily="34" charset="-122"/>
+                
+                
+                <a:cs typeface="Arial" pitchFamily="34" charset="-120"/>
+                
+              
+              </a:rPr>
+              
+              
+              <a:t>External audit → Mainnet · Circle USDC · GeoBlock (frontend compliance)</a:t>
+              
+            
+            </a:r>
+            
+            
+            <a:endParaRPr lang="en-US" sz="1000" dirty="0"/>
+            
+          
+          </a:p>
+          
+        
+        </p:txBody>
+        
+      
+      </p:sp>
+      
+      
+      <p:sp>
+        
+        
+        <p:nvSpPr>
+          
+          
+          <p:cNvPr id="21" name="Shape 19"/>
+          
+          
+          <p:cNvSpPr/>
+          
+          
+          <p:nvPr/>
+          
+        
+        </p:nvSpPr>
+        
+        
+        <p:spPr>
+          
+          
+          <a:xfrm>
+            
+            
+            <a:off x="4754880" y="3063240"/>
+            
+            
+            <a:ext cx="4023360" cy="1691640"/>
+            
+          
+          </a:xfrm>
+          
+          
+          <a:prstGeom prst="rect">
+            
+            
+            <a:avLst/>
+            
+          
+          </a:prstGeom>
+          
+          
+          <a:solidFill>
+            
+            
+            <a:srgbClr val="FFFFFF"/>
+            
+          
+          </a:solidFill>
+          
+          
+          <a:ln w="12700">
+            
+            
+            <a:solidFill>
+              
+              
+              <a:srgbClr val="E2E8F0"/>
+              
+            
+            </a:solidFill>
+            
+            
+            <a:prstDash val="solid"/>
+            
+          
+          </a:ln>
+          
+          
+          <a:effectLst>
+            
+             
+            
+            <a:outerShdw sx="100000" sy="100000" kx="0" ky="0" algn="bl" rotWithShape="0" blurRad="50800" dist="25400" dir="8100000">
+              
+               
+              
+              <a:srgbClr val="000000">
+                
+                 
+                
+                <a:alpha val="12000"/>
+                
+              
+              </a:srgbClr>
+              
+               
+            
+            </a:outerShdw>
+            
+          
+          </a:effectLst>
+          
+        
+        </p:spPr>
+        
+      
+      </p:sp>
+      
+      
+      <p:sp>
+        
+        
+        <p:nvSpPr>
+          
+          
+          <p:cNvPr id="22" name="Shape 20"/>
+          
+          
+          <p:cNvSpPr/>
+          
+          
+          <p:nvPr/>
+          
+        
+        </p:nvSpPr>
+        
+        
+        <p:spPr>
+          
+          
+          <a:xfrm>
+            
+            
+            <a:off x="4937760" y="3246120"/>
+            
+            
+            <a:ext cx="502920" cy="502920"/>
+            
+          
+          </a:xfrm>
+          
+          
+          <a:prstGeom prst="ellipse">
+            
+            
+            <a:avLst/>
+            
+          
+          </a:prstGeom>
+          
+          
+          <a:solidFill>
+            
+            
+            <a:srgbClr val="21295C"/>
+            
+          
+          </a:solidFill>
+          
+          
+          <a:ln/>
+          
+        
+        </p:spPr>
+        
+      
+      </p:sp>
+      
+      
+      <p:sp>
+        
+        
+        <p:nvSpPr>
+          
+          
+          <p:cNvPr id="23" name="Text 21"/>
+          
+          
+          <p:cNvSpPr/>
+          
+          
+          <p:nvPr/>
+          
+        
+        </p:nvSpPr>
+        
+        
+        <p:spPr>
+          
+          
+          <a:xfrm>
+            
+            
+            <a:off x="4937760" y="3246120"/>
+            
+            
+            <a:ext cx="502920" cy="502920"/>
+            
+          
+          </a:xfrm>
+          
+          
+          <a:prstGeom prst="rect">
+            
+            
+            <a:avLst/>
+            
+          
+          </a:prstGeom>
+          
+          
+          <a:noFill/>
+          
+          
+          <a:ln/>
+          
+        
+        </p:spPr>
+        
+        
+        <p:txBody>
+          
+          
+          <a:bodyPr wrap="square" lIns="0" tIns="0" rIns="0" bIns="0" rtlCol="0" anchor="ctr"/>
+          
+          
+          <a:lstStyle/>
+          
+          
+          <a:p>
+            
+            
+            <a:pPr algn="ctr" indent="0" marL="0">
+              
+              
+              <a:buNone/>
+              
+            
+            </a:pPr>
+            
+            
+            <a:r>
+              
+              
+              <a:rPr lang="en-US" sz="1600" dirty="0">
+                
+                
+                <a:solidFill>
+                  
+                  
+                  <a:srgbClr val="000000"/>
+                  
+                
+                </a:solidFill>
+                
+              
+              </a:rPr>
+              
+              
+              <a:t>🎯</a:t>
+              
+            
+            </a:r>
+            
+            
+            <a:endParaRPr lang="en-US" sz="1600" dirty="0"/>
+            
+          
+          </a:p>
+          
+        
+        </p:txBody>
+        
+      
+      </p:sp>
+      
+      
+      <p:sp>
+        
+        
+        <p:nvSpPr>
+          
+          
+          <p:cNvPr id="24" name="Text 22"/>
+          
+          
+          <p:cNvSpPr/>
+          
+          
+          <p:nvPr/>
+          
+        
+        </p:nvSpPr>
+        
+        
+        <p:spPr>
+          
+          
+          <a:xfrm>
+            
+            
+            <a:off x="5532120" y="3227832"/>
+            
+            
+            <a:ext cx="3108960" cy="365760"/>
+            
+          
+          </a:xfrm>
+          
+          
+          <a:prstGeom prst="rect">
+            
+            
+            <a:avLst/>
+            
+          
+          </a:prstGeom>
+          
+          
+          <a:noFill/>
+          
+          
+          <a:ln/>
+          
+        
+        </p:spPr>
+        
+        
+        <p:txBody>
+          
+          
+          <a:bodyPr wrap="square" lIns="0" tIns="0" rIns="0" bIns="0" rtlCol="0" anchor="ctr"/>
+          
+          
+          <a:lstStyle/>
+          
+          
+          <a:p>
+            
+            
+            <a:pPr indent="0" marL="0">
+              
+              
+              <a:buNone/>
+              
+            
+            </a:pPr>
+            
+            
+            <a:r>
+              
+              
+              <a:rPr lang="en-US" sz="1400" b="1" dirty="0">
+                
+                
+                <a:solidFill>
+                  
+                  
+                  <a:srgbClr val="065A82"/>
+                  
+                
+                </a:solidFill>
+                
+                
+                <a:latin typeface="Arial" pitchFamily="34" charset="0"/>
+                
+                
+                <a:ea typeface="Arial" pitchFamily="34" charset="-122"/>
+                
+                
+                <a:cs typeface="Arial" pitchFamily="34" charset="-120"/>
+                
+              
+              </a:rPr>
+              
+              
+              <a:t>Long-Term Vision</a:t>
+              
+            
+            </a:r>
+            
+            
+            <a:endParaRPr lang="en-US" sz="1400" dirty="0"/>
+            
+          
+          </a:p>
+          
+        
+        </p:txBody>
+        
+      
+      </p:sp>
+      
+      
+      <p:sp>
+        
+        
+        <p:nvSpPr>
+          
+          
+          <p:cNvPr id="25" name="Text 23"/>
+          
+          
+          <p:cNvSpPr/>
+          
+          
+          <p:nvPr/>
+          
+        
+        </p:nvSpPr>
+        
+        
+        <p:spPr>
+          
+          
+          <a:xfrm>
+            
+            
+            <a:off x="4937760" y="3749040"/>
+            
+            
+            <a:ext cx="3657600" cy="914400"/>
+            
+          
+          </a:xfrm>
+          
+          
+          <a:prstGeom prst="rect">
+            
+            
+            <a:avLst/>
+            
+          
+          </a:prstGeom>
+          
+          
+          <a:noFill/>
+          
+          
+          <a:ln/>
+          
+        
+        </p:spPr>
+        
+        
+        <p:txBody>
+          
+          
+          <a:bodyPr wrap="square" rtlCol="0" anchor="t"/>
+          
+          
+          <a:lstStyle/>
+          
+          
+          <a:p>
+            
+            
+            <a:pPr marL="342900" indent="-342900">
+              
+              
+              <a:buSzPct val="100000"/>
+              
+              
+              <a:buChar char="•"/>
+              
+            
+            </a:pPr>
+            
+            
+            <a:r>
+              
+              
+              <a:rPr lang="en-US" sz="1000" dirty="0">
+                
+                
+                <a:solidFill>
+                  
+                  
+                  <a:srgbClr val="1E293B"/>
+                  
+                
+                </a:solidFill>
+                
+                
+                <a:latin typeface="Arial" pitchFamily="34" charset="0"/>
+                
+                
+                <a:ea typeface="Arial" pitchFamily="34" charset="-122"/>
+                
+                
+                <a:cs typeface="Arial" pitchFamily="34" charset="-120"/>
+                
+              
+              </a:rPr>
+              
+              
+              <a:t>Become Sui's infrastructure layer for probability derivatives + paid knowledge</a:t>
+              
+            
+            </a:r>
+            
+            
+            <a:endParaRPr lang="en-US" sz="1000" dirty="0"/>
+            
+          
+          </a:p>
+          
+          
+          <a:p>
+            
+            
+            <a:pPr marL="342900" indent="-342900">
+              
+              
+              <a:buSzPct val="100000"/>
+              
+              
+              <a:buChar char="•"/>
+              
+            
+            </a:pPr>
+            
+            
+            <a:r>
+              
+              
+              <a:rPr lang="en-US" sz="1000" dirty="0">
+                
+                
+                <a:solidFill>
+                  
+                  
+                  <a:srgbClr val="1E293B"/>
+                  
+                
+                </a:solidFill>
+                
+                
+                <a:latin typeface="Arial" pitchFamily="34" charset="0"/>
+                
+                
+                <a:ea typeface="Arial" pitchFamily="34" charset="-122"/>
+                
+                
+                <a:cs typeface="Arial" pitchFamily="34" charset="-120"/>
+                
+              
+              </a:rPr>
+              
+              
+              <a:t>Serve retail traders, LPs, prophets, and quant institutions</a:t>
+              
+            
+            </a:r>
+            
+            
+            <a:endParaRPr lang="en-US" sz="1000" dirty="0"/>
+            
+          
+          </a:p>
+          
+          
+          <a:p>
+            
+            
+            <a:pPr marL="342900" indent="-342900">
+              
+              
+              <a:buSzPct val="100000"/>
+              
+              
+              <a:buChar char="•"/>
+              
+            
+            </a:pPr>
+            
+            
+            <a:r>
+              
+              
+              <a:rPr lang="en-US" sz="1000" dirty="0">
+                
+                
+                <a:solidFill>
+                  
+                  
+                  <a:srgbClr val="1E293B"/>
+                  
+                
+                </a:solidFill>
+                
+                
+                <a:latin typeface="Arial" pitchFamily="34" charset="0"/>
+                
+                
+                <a:ea typeface="Arial" pitchFamily="34" charset="-122"/>
+                
+                
+                <a:cs typeface="Arial" pitchFamily="34" charset="-120"/>
+                
+              
+              </a:rPr>
+              
+              
+              <a:t>Full EventRoot migration · SDK / Quant API open access</a:t>
+              
+            
+            </a:r>
+            
+            
+            <a:endParaRPr lang="en-US" sz="1000" dirty="0"/>
+            
+          
+          </a:p>
+          
+          
+          <a:p>
+            
+            
+            <a:pPr marL="342900" indent="-342900">
+              
+              
+              <a:buSzPct val="100000"/>
+              
+              
+              <a:buChar char="•"/>
+              
+            
+            </a:pPr>
+            
+            
+            <a:r>
+              
+              
+              <a:rPr lang="en-US" sz="1000" dirty="0">
+                
+                
+                <a:solidFill>
+                  
+                  
+                  <a:srgbClr val="1E293B"/>
+                  
+                
+                </a:solidFill>
+                
+                
+                <a:latin typeface="Arial" pitchFamily="34" charset="0"/>
+                
+                
+                <a:ea typeface="Arial" pitchFamily="34" charset="-122"/>
+                
+                
+                <a:cs typeface="Arial" pitchFamily="34" charset="-120"/>
+                
+              
+              </a:rPr>
+              
+              
+              <a:t>Replace fragmented Yes/No with on-chain PDF · replace fake signals with forced audit</a:t>
+              
+            
+            </a:r>
+            
+            
+            <a:endParaRPr lang="en-US" sz="1000" dirty="0"/>
+            
+          
+          </a:p>
+          
+        
+        </p:txBody>
+        
+      
+      </p:sp>
+      
+    
+    </p:spTree>
+    
+  
+  </p:cSld>
+  
+  
+  <p:clrMapOvr>
+    
+    
+    <a:masterClrMapping/>
+    
+  
+  </p:clrMapOvr>
+  
+
+</p:sld>
+
 </file>
 
 <file path=ppt/slides/slide2.xml><?xml version="1.0" encoding="utf-8"?>

</xml_diff>

<commit_message>
feat(prophet): paid prophecy BCS hiding and wallet-paid commits
Remove frontend Gas Station sponsorship so Prophet txs are paid from the user wallet. Add prophet_plain on-chain module with matching TS/keeper codecs to hide paid predictions until audit, republish testnet, and update scripts and docs.

Co-authored-by: Cursor <cursoragent@cursor.com>
</commit_message>
<xml_diff>
--- a/docs/presentations/X-Market-Sui-Overview.en.pptx
+++ b/docs/presentations/X-Market-Sui-Overview.en.pptx
@@ -3072,7 +3072,7 @@
                 <a:ea typeface="Arial" pitchFamily="34" charset="-122"/>
                 <a:cs typeface="Arial" pitchFamily="34" charset="-120"/>
               </a:rPr>
-              <a:t>Lower cognitive barrier, focus on trading</a:t>
+              <a:t>On-chain txs paid with wallet SUI gas</a:t>
             </a:r>
             <a:endParaRPr lang="en-US" sz="1000" dirty="0"/>
           </a:p>
@@ -4900,7 +4900,7 @@
                 <a:ea typeface="Arial" pitchFamily="34" charset="-122"/>
                 <a:cs typeface="Arial" pitchFamily="34" charset="-120"/>
               </a:rPr>
-              <a:t>9+</a:t>
+              <a:t>8+</a:t>
             </a:r>
             <a:endParaRPr lang="en-US" sz="2800" dirty="0"/>
           </a:p>
@@ -12580,7 +12580,7 @@
               </a:rPr>
               
               
-              <a:t>9+ off-chain microservices · Docker orchestration production-ready</a:t>
+              <a:t>8+ off-chain microservices · Docker orchestration production-ready</a:t>
               
             
             </a:r>

</xml_diff>